<commit_message>
Update PowerPoint presentation content
Modified the binary content of `ST10382638_POE_PART_3.pptx`. The exact changes are unspecified but may include updates to slide content, formatting, or embedded elements.
</commit_message>
<xml_diff>
--- a/ST10382638_POE_PART_3.pptx
+++ b/ST10382638_POE_PART_3.pptx
@@ -133,18 +133,18 @@
   <pc:docChgLst>
     <pc:chgData name="Luc de Marillac St Julien" userId="21cd25a9-5621-41d6-9bf5-79ece09f8b69" providerId="ADAL" clId="{584165F8-D849-4BC6-A6BB-31372731BEBE}"/>
     <pc:docChg chg="undo redo custSel addSld delSld modSld">
-      <pc:chgData name="Luc de Marillac St Julien" userId="21cd25a9-5621-41d6-9bf5-79ece09f8b69" providerId="ADAL" clId="{584165F8-D849-4BC6-A6BB-31372731BEBE}" dt="2025-11-21T19:25:55.733" v="866" actId="20577"/>
+      <pc:chgData name="Luc de Marillac St Julien" userId="21cd25a9-5621-41d6-9bf5-79ece09f8b69" providerId="ADAL" clId="{584165F8-D849-4BC6-A6BB-31372731BEBE}" dt="2025-11-21T19:32:45.142" v="881" actId="20577"/>
       <pc:docMkLst>
         <pc:docMk/>
       </pc:docMkLst>
       <pc:sldChg chg="modSp mod">
-        <pc:chgData name="Luc de Marillac St Julien" userId="21cd25a9-5621-41d6-9bf5-79ece09f8b69" providerId="ADAL" clId="{584165F8-D849-4BC6-A6BB-31372731BEBE}" dt="2025-11-21T19:25:55.733" v="866" actId="20577"/>
+        <pc:chgData name="Luc de Marillac St Julien" userId="21cd25a9-5621-41d6-9bf5-79ece09f8b69" providerId="ADAL" clId="{584165F8-D849-4BC6-A6BB-31372731BEBE}" dt="2025-11-21T19:32:45.142" v="881" actId="20577"/>
         <pc:sldMkLst>
           <pc:docMk/>
           <pc:sldMk cId="684151441" sldId="256"/>
         </pc:sldMkLst>
         <pc:spChg chg="mod">
-          <ac:chgData name="Luc de Marillac St Julien" userId="21cd25a9-5621-41d6-9bf5-79ece09f8b69" providerId="ADAL" clId="{584165F8-D849-4BC6-A6BB-31372731BEBE}" dt="2025-11-21T19:25:55.733" v="866" actId="20577"/>
+          <ac:chgData name="Luc de Marillac St Julien" userId="21cd25a9-5621-41d6-9bf5-79ece09f8b69" providerId="ADAL" clId="{584165F8-D849-4BC6-A6BB-31372731BEBE}" dt="2025-11-21T19:32:45.142" v="881" actId="20577"/>
           <ac:spMkLst>
             <pc:docMk/>
             <pc:sldMk cId="684151441" sldId="256"/>
@@ -11235,6 +11235,19 @@
             </a:pPr>
             <a:r>
               <a:rPr lang="en-US" dirty="0"/>
+              <a:t>ST10382638</a:t>
+            </a:r>
+          </a:p>
+          <a:p>
+            <a:pPr indent="-228600">
+              <a:lnSpc>
+                <a:spcPct val="120000"/>
+              </a:lnSpc>
+              <a:buFont typeface="Arial" panose="020B0604020202020204" pitchFamily="34" charset="0"/>
+              <a:buChar char="•"/>
+            </a:pPr>
+            <a:r>
+              <a:rPr lang="en-US" dirty="0"/>
               <a:t>PROG6212</a:t>
             </a:r>
           </a:p>
@@ -11260,12 +11273,8 @@
               <a:buChar char="•"/>
             </a:pPr>
             <a:r>
-              <a:rPr lang="en-US"/>
-              <a:t>Lecturer: Youn-Soo </a:t>
-            </a:r>
-            <a:r>
               <a:rPr lang="en-US" dirty="0"/>
-              <a:t>Kim</a:t>
+              <a:t>Lecturer: Youn-Soo Kim</a:t>
             </a:r>
           </a:p>
         </p:txBody>

</xml_diff>